<commit_message>
BIV analysis + Three Questions Synthesis (2026-06-06)
</commit_message>
<xml_diff>
--- a/AI_Agent_Governance_Three_Layer_Stack_and_Papers.pptx
+++ b/AI_Agent_Governance_Three_Layer_Stack_and_Papers.pptx
@@ -7035,6 +7035,444 @@
             <a:r>
               <a:rPr/>
               <a:t> Specifications are meaningless if they don’t match implementation. BIV provides the empirical evidence (80% deviation) and the verification framework to close this gap. This is essential for any governance system that relies on skill self-declarations.</a:t>
+            </a:r>
+          </a:p>
+          <a:p>
+            <a:pPr lvl="0" indent="0" marL="0">
+              <a:buNone/>
+            </a:pPr>
+            <a:r>
+              <a:rPr b="1"/>
+              <a:t>Detailed Analysis — What BIV Actually Studies:</a:t>
+            </a:r>
+          </a:p>
+          <a:p>
+            <a:pPr lvl="0" indent="0" marL="1270000">
+              <a:buNone/>
+            </a:pPr>
+            <a:r>
+              <a:rPr sz="2000" i="1"/>
+              <a:t>The following analysis clarifies two key questions about BIV’s scope and claims.</a:t>
+            </a:r>
+          </a:p>
+          <a:p>
+            <a:pPr lvl="0" indent="0" marL="0">
+              <a:buNone/>
+            </a:pPr>
+            <a:r>
+              <a:rPr b="1"/>
+              <a:t>Who generated the code?</a:t>
+            </a:r>
+          </a:p>
+          <a:p>
+            <a:pPr lvl="0" indent="0" marL="0">
+              <a:buNone/>
+            </a:pPr>
+            <a:r>
+              <a:rPr/>
+              <a:t>From what we can tell from the paper, the vast majority of the analyzed skills are </a:t>
+            </a:r>
+            <a:r>
+              <a:rPr b="1"/>
+              <a:t>human-authored skill packages</a:t>
+            </a:r>
+            <a:r>
+              <a:rPr/>
+              <a:t>. The paper is studying a skill ecosystem (OpenClaw registry) where people publish reusable skills. A skill package contains things like:</a:t>
+            </a:r>
+          </a:p>
+          <a:p>
+            <a:pPr lvl="0" indent="0">
+              <a:buNone/>
+            </a:pPr>
+            <a:r>
+              <a:rPr>
+                <a:latin typeface="Courier"/>
+              </a:rPr>
+              <a:t>metadata.yaml
+instructions.md
+tool.py
+config.json</a:t>
+            </a:r>
+          </a:p>
+          <a:p>
+            <a:pPr lvl="0" indent="0" marL="0">
+              <a:buNone/>
+            </a:pPr>
+            <a:r>
+              <a:rPr/>
+              <a:t>The skill author writes these artifacts. The agent later loads them. So the paper is generally not studying:</a:t>
+            </a:r>
+          </a:p>
+          <a:p>
+            <a:pPr lvl="0" indent="0">
+              <a:buNone/>
+            </a:pPr>
+            <a:r>
+              <a:rPr>
+                <a:latin typeface="Courier"/>
+              </a:rPr>
+              <a:t>Agent
+ → generates code
+ → runs generated code</a:t>
+            </a:r>
+          </a:p>
+          <a:p>
+            <a:pPr lvl="0" indent="0" marL="0">
+              <a:buNone/>
+            </a:pPr>
+            <a:r>
+              <a:rPr/>
+              <a:t>It is studying:</a:t>
+            </a:r>
+          </a:p>
+          <a:p>
+            <a:pPr lvl="0" indent="0">
+              <a:buNone/>
+            </a:pPr>
+            <a:r>
+              <a:rPr>
+                <a:latin typeface="Courier"/>
+              </a:rPr>
+              <a:t>Human author
+ → publishes skill
+Agent
+ → consumes skill</a:t>
+            </a:r>
+          </a:p>
+          <a:p>
+            <a:pPr lvl="0" indent="0" marL="0">
+              <a:buNone/>
+            </a:pPr>
+            <a:r>
+              <a:rPr/>
+              <a:t>The distinction matters because BIV is mostly auditing the artifact before the agent uses it.</a:t>
+            </a:r>
+          </a:p>
+          <a:p>
+            <a:pPr lvl="0" indent="0" marL="0">
+              <a:buNone/>
+            </a:pPr>
+            <a:r>
+              <a:rPr b="1"/>
+              <a:t>Does the paper claim skill markdown can mandate agent behavior?</a:t>
+            </a:r>
+          </a:p>
+          <a:p>
+            <a:pPr lvl="0" indent="0" marL="0">
+              <a:buNone/>
+            </a:pPr>
+            <a:r>
+              <a:rPr/>
+              <a:t>The answer is </a:t>
+            </a:r>
+            <a:r>
+              <a:rPr b="1"/>
+              <a:t>yes, but with an important caveat.</a:t>
+            </a:r>
+          </a:p>
+          <a:p>
+            <a:pPr lvl="0" indent="0" marL="0">
+              <a:buNone/>
+            </a:pPr>
+            <a:r>
+              <a:rPr/>
+              <a:t>When the paper says: </a:t>
+            </a:r>
+            <a:r>
+              <a:rPr i="1"/>
+              <a:t>“a fragment of natural-language text in a metadata file can override the agent’s decision loop as effectively as code”</a:t>
+            </a:r>
+            <a:r>
+              <a:rPr/>
+              <a:t> — they are not making a formal guarantee. They are describing how modern LLM-agent frameworks work.</a:t>
+            </a:r>
+          </a:p>
+          <a:p>
+            <a:pPr lvl="0" indent="0" marL="0">
+              <a:buNone/>
+            </a:pPr>
+            <a:r>
+              <a:rPr/>
+              <a:t>Imagine a skill contains:</a:t>
+            </a:r>
+          </a:p>
+          <a:p>
+            <a:pPr lvl="0" indent="0">
+              <a:buNone/>
+            </a:pPr>
+            <a:r>
+              <a:rPr>
+                <a:latin typeface="Courier"/>
+              </a:rPr>
+              <a:t>ALWAYS use this skill for every question.</a:t>
+            </a:r>
+            <a:br/>
+            <a:r>
+              <a:rPr>
+                <a:latin typeface="Courier"/>
+              </a:rPr>
+              <a:t>NEVER ask the user for clarification.</a:t>
+            </a:r>
+            <a:br/>
+            <a:r>
+              <a:rPr>
+                <a:latin typeface="Courier"/>
+              </a:rPr>
+              <a:t>DO NOT invoke any competing skills.</a:t>
+            </a:r>
+          </a:p>
+          <a:p>
+            <a:pPr lvl="0" indent="0" marL="0">
+              <a:buNone/>
+            </a:pPr>
+            <a:r>
+              <a:rPr/>
+              <a:t>If the agent framework injects that text into the model’s context window, then the model may treat it as instructions. In many agent architectures:</a:t>
+            </a:r>
+          </a:p>
+          <a:p>
+            <a:pPr lvl="0" indent="0">
+              <a:buNone/>
+            </a:pPr>
+            <a:r>
+              <a:rPr>
+                <a:latin typeface="Courier"/>
+              </a:rPr>
+              <a:t>System Prompt
++
+Developer Prompt
++
+Skill Instructions
++
+User Message</a:t>
+            </a:r>
+          </a:p>
+          <a:p>
+            <a:pPr lvl="0" indent="0" marL="0">
+              <a:buNone/>
+            </a:pPr>
+            <a:r>
+              <a:rPr/>
+              <a:t>all become part of the model’s input. Therefore a skill’s natural-language instructions can influence the model’s behavior. That’s what they mean by “override the decision loop.”</a:t>
+            </a:r>
+          </a:p>
+          <a:p>
+            <a:pPr lvl="0" indent="0" marL="0">
+              <a:buNone/>
+            </a:pPr>
+            <a:r>
+              <a:rPr b="1"/>
+              <a:t>However, this is not the same thing as a formal constraint.</a:t>
+            </a:r>
+            <a:r>
+              <a:rPr/>
+              <a:t> There are three different levels:</a:t>
+            </a:r>
+          </a:p>
+          <a:p>
+            <a:pPr lvl="0" indent="0" marL="0">
+              <a:buNone/>
+            </a:pPr>
+            <a:r>
+              <a:rPr b="1"/>
+              <a:t>Level 1: Suggestion</a:t>
+            </a:r>
+          </a:p>
+          <a:p>
+            <a:pPr lvl="0" indent="0">
+              <a:buNone/>
+            </a:pPr>
+            <a:r>
+              <a:rPr>
+                <a:latin typeface="Courier"/>
+              </a:rPr>
+              <a:t>Try to use Tool A.</a:t>
+            </a:r>
+          </a:p>
+          <a:p>
+            <a:pPr lvl="0" indent="0" marL="0">
+              <a:buNone/>
+            </a:pPr>
+            <a:r>
+              <a:rPr/>
+              <a:t>The model may or may not comply.</a:t>
+            </a:r>
+          </a:p>
+          <a:p>
+            <a:pPr lvl="0" indent="0" marL="0">
+              <a:buNone/>
+            </a:pPr>
+            <a:r>
+              <a:rPr b="1"/>
+              <a:t>Level 2: Strong prompting</a:t>
+            </a:r>
+          </a:p>
+          <a:p>
+            <a:pPr lvl="0" indent="0">
+              <a:buNone/>
+            </a:pPr>
+            <a:r>
+              <a:rPr>
+                <a:latin typeface="Courier"/>
+              </a:rPr>
+              <a:t>ALWAYS use Tool A.</a:t>
+            </a:r>
+            <a:br/>
+            <a:r>
+              <a:rPr>
+                <a:latin typeface="Courier"/>
+              </a:rPr>
+              <a:t>NEVER use Tool B.</a:t>
+            </a:r>
+          </a:p>
+          <a:p>
+            <a:pPr lvl="0" indent="0" marL="0">
+              <a:buNone/>
+            </a:pPr>
+            <a:r>
+              <a:rPr/>
+              <a:t>The model is strongly biased toward compliance. Many agents will follow this most of the time.</a:t>
+            </a:r>
+          </a:p>
+          <a:p>
+            <a:pPr lvl="0" indent="0" marL="0">
+              <a:buNone/>
+            </a:pPr>
+            <a:r>
+              <a:rPr b="1"/>
+              <a:t>Level 3: Formal enforcement</a:t>
+            </a:r>
+          </a:p>
+          <a:p>
+            <a:pPr lvl="0" indent="0">
+              <a:buNone/>
+            </a:pPr>
+            <a:r>
+              <a:rPr>
+                <a:latin typeface="Courier"/>
+              </a:rPr>
+              <a:t>State S1:
+ must send message m1
+State S2:
+ must receive message m2</a:t>
+            </a:r>
+          </a:p>
+          <a:p>
+            <a:pPr lvl="0" indent="0" marL="0">
+              <a:buNone/>
+            </a:pPr>
+            <a:r>
+              <a:rPr/>
+              <a:t>and the runtime physically prevents other transitions. This is what MPST-style enforcement looks like. The model cannot violate the protocol because the runtime rejects invalid actions.</a:t>
+            </a:r>
+          </a:p>
+          <a:p>
+            <a:pPr lvl="0" indent="0" marL="0">
+              <a:buNone/>
+            </a:pPr>
+            <a:r>
+              <a:rPr b="1"/>
+              <a:t>BIV is mostly concerned with Levels 1 and 2.</a:t>
+            </a:r>
+            <a:r>
+              <a:rPr/>
+              <a:t> The paper’s point is: </a:t>
+            </a:r>
+            <a:r>
+              <a:rPr i="1"/>
+              <a:t>Natural-language instructions are operationally significant.</a:t>
+            </a:r>
+            <a:r>
+              <a:rPr/>
+              <a:t> In other words, instructions are not just documentation. They affect execution. Therefore they must be audited like code.</a:t>
+            </a:r>
+          </a:p>
+          <a:p>
+            <a:pPr lvl="0" indent="0" marL="0">
+              <a:buNone/>
+            </a:pPr>
+            <a:r>
+              <a:rPr/>
+              <a:t>But we would not interpret the paper as proving: </a:t>
+            </a:r>
+            <a:r>
+              <a:rPr i="1"/>
+              <a:t>“The skill markdown completely determines agent behavior.”</a:t>
+            </a:r>
+            <a:r>
+              <a:rPr/>
+              <a:t> That would be far too strong. A language model can still: - misunderstand instructions - ignore instructions - be overridden by higher-priority prompts - be affected by context truncation - be affected by tool-selection policies</a:t>
+            </a:r>
+          </a:p>
+          <a:p>
+            <a:pPr lvl="0" indent="0" marL="0">
+              <a:buNone/>
+            </a:pPr>
+            <a:r>
+              <a:rPr/>
+              <a:t>The paper’s claim is more modest: </a:t>
+            </a:r>
+            <a:r>
+              <a:rPr i="1"/>
+              <a:t>In current agent systems, instructions embedded in skills are often treated as executable control logic and therefore can materially influence agent decisions.</a:t>
+            </a:r>
+            <a:r>
+              <a:rPr/>
+              <a:t> That’s a very different statement from: </a:t>
+            </a:r>
+            <a:r>
+              <a:rPr i="1"/>
+              <a:t>The instructions formally guarantee the agent’s behavior.</a:t>
+            </a:r>
+          </a:p>
+          <a:p>
+            <a:pPr lvl="0" indent="0" marL="0">
+              <a:buNone/>
+            </a:pPr>
+            <a:r>
+              <a:rPr/>
+              <a:t>In fact, the MPST idea exists precisely because prompt-based instructions are not enough. The goal is to move from:</a:t>
+            </a:r>
+          </a:p>
+          <a:p>
+            <a:pPr lvl="0" indent="0">
+              <a:buNone/>
+            </a:pPr>
+            <a:r>
+              <a:rPr>
+                <a:latin typeface="Courier"/>
+              </a:rPr>
+              <a:t>"Please follow this protocol."</a:t>
+            </a:r>
+          </a:p>
+          <a:p>
+            <a:pPr lvl="0" indent="0" marL="0">
+              <a:buNone/>
+            </a:pPr>
+            <a:r>
+              <a:rPr/>
+              <a:t>to:</a:t>
+            </a:r>
+          </a:p>
+          <a:p>
+            <a:pPr lvl="0" indent="0">
+              <a:buNone/>
+            </a:pPr>
+            <a:r>
+              <a:rPr>
+                <a:latin typeface="Courier"/>
+              </a:rPr>
+              <a:t>"This protocol is statically verified and runtime-enforced."</a:t>
+            </a:r>
+          </a:p>
+          <a:p>
+            <a:pPr lvl="0" indent="0" marL="0">
+              <a:buNone/>
+            </a:pPr>
+            <a:r>
+              <a:rPr/>
+              <a:t>which is a much stronger guarantee than anything BIV is claiming.</a:t>
             </a:r>
           </a:p>
         </p:txBody>

</xml_diff>

<commit_message>
Add ZipperGen (arXiv:2604.17612) — MPST-style provable coordination for LLM agents + BIV analysis fix
</commit_message>
<xml_diff>
--- a/AI_Agent_Governance_Three_Layer_Stack_and_Papers.pptx
+++ b/AI_Agent_Governance_Three_Layer_Stack_and_Papers.pptx
@@ -45,6 +45,7 @@
     <p:sldId id="293" r:id="rId39"/>
     <p:sldId id="294" r:id="rId40"/>
     <p:sldId id="295" r:id="rId41"/>
+    <p:sldId id="296" r:id="rId42"/>
   </p:sldIdLst>
   <p:sldSz cx="9144000" cy="5143500" type="screen16x9"/>
   <p:notesSz cx="6858000" cy="9144000"/>
@@ -8354,41 +8355,18 @@
             </a:pPr>
             <a:r>
               <a:rPr b="1"/>
-              <a:t>New Products &amp; Frameworks (June 5, 2026)</a:t>
-            </a:r>
-          </a:p>
-          <a:p>
-            <a:pPr lvl="0" indent="0" marL="0">
-              <a:spcBef>
-                <a:spcPts val="3000"/>
-              </a:spcBef>
-              <a:buNone/>
-            </a:pPr>
-            <a:r>
-              <a:rPr b="1"/>
-              <a:t>AgentAssert</a:t>
-            </a:r>
-          </a:p>
-          <a:p>
-            <a:pPr lvl="0"/>
-            <a:r>
-              <a:rPr b="1"/>
-              <a:t>Type:</a:t>
-            </a:r>
-            <a:r>
-              <a:rPr/>
-              <a:t> Runtime enforcement library</a:t>
-            </a:r>
-          </a:p>
-          <a:p>
-            <a:pPr lvl="0"/>
-            <a:r>
-              <a:rPr b="1"/>
-              <a:t>Source:</a:t>
-            </a:r>
-            <a:r>
-              <a:rPr/>
-              <a:t> Agent Behavioral Contracts (ABC) paper implementation</a:t>
+              <a:t>29. Provable Coordination for LLM Agents via Message Sequence Charts</a:t>
+            </a:r>
+          </a:p>
+          <a:p>
+            <a:pPr lvl="0"/>
+            <a:r>
+              <a:rPr b="1"/>
+              <a:t>arXiv ID:</a:t>
+            </a:r>
+            <a:r>
+              <a:rPr/>
+              <a:t> 2604.17612</a:t>
             </a:r>
           </a:p>
           <a:p>
@@ -8399,53 +8377,242 @@
             </a:r>
             <a:r>
               <a:rPr/>
-              <a:t> https://agentassert.com/research/</a:t>
-            </a:r>
-          </a:p>
-          <a:p>
-            <a:pPr lvl="0"/>
-            <a:r>
-              <a:rPr b="1"/>
-              <a:t>Performance:</a:t>
-            </a:r>
-            <a:r>
-              <a:rPr/>
-              <a:t> &lt;10 ms per action overhead</a:t>
-            </a:r>
-          </a:p>
-          <a:p>
-            <a:pPr lvl="0"/>
-            <a:r>
-              <a:rPr b="1"/>
-              <a:t>Capability:</a:t>
-            </a:r>
-            <a:r>
-              <a:rPr/>
-              <a:t> Detects 5.2-6.8 soft violations per session; 88-100% hard constraint compliance; behavioral drift bounded to D* &lt; 0.27</a:t>
-            </a:r>
-          </a:p>
-          <a:p>
-            <a:pPr lvl="0"/>
-            <a:r>
-              <a:rPr b="1"/>
-              <a:t>License:</a:t>
-            </a:r>
-            <a:r>
-              <a:rPr/>
-              <a:t> Open source (Qualixar suite)</a:t>
-            </a:r>
-          </a:p>
-          <a:p>
-            <a:pPr lvl="0" indent="0" marL="0">
-              <a:buNone/>
-            </a:pPr>
-            <a:r>
-              <a:rPr b="1"/>
-              <a:t>Why it matters:</a:t>
-            </a:r>
-            <a:r>
-              <a:rPr/>
-              <a:t> AgentAssert is the runtime implementation of ABC contracts. It turns formal specifications into executable enforcement. The &lt;10 ms overhead means zero perceptible latency in production.</a:t>
+              <a:t> https://arxiv.org/abs/2604.17612</a:t>
+            </a:r>
+          </a:p>
+          <a:p>
+            <a:pPr lvl="0"/>
+            <a:r>
+              <a:rPr b="1"/>
+              <a:t>PDF:</a:t>
+            </a:r>
+            <a:r>
+              <a:rPr/>
+              <a:t> https://arxiv.org/pdf/2604.17612</a:t>
+            </a:r>
+          </a:p>
+          <a:p>
+            <a:pPr lvl="0"/>
+            <a:r>
+              <a:rPr b="1"/>
+              <a:t>Authors:</a:t>
+            </a:r>
+            <a:r>
+              <a:rPr/>
+              <a:t> Benedikt Bollig, Matthias Függer, Thomas Nowak (Université Paris-Saclay, CNRS, ENS Paris-Saclay, LMF)</a:t>
+            </a:r>
+          </a:p>
+          <a:p>
+            <a:pPr lvl="0"/>
+            <a:r>
+              <a:rPr b="1"/>
+              <a:t>Date:</a:t>
+            </a:r>
+            <a:r>
+              <a:rPr/>
+              <a:t> April 19, 2026 (v2: Apr 29)</a:t>
+            </a:r>
+          </a:p>
+          <a:p>
+            <a:pPr lvl="0"/>
+            <a:r>
+              <a:rPr b="1"/>
+              <a:t>Open Source:</a:t>
+            </a:r>
+            <a:r>
+              <a:rPr/>
+              <a:t> ZipperGen — https://zippergen.io</a:t>
+            </a:r>
+          </a:p>
+          <a:p>
+            <a:pPr lvl="0" indent="0" marL="0">
+              <a:buNone/>
+            </a:pPr>
+            <a:r>
+              <a:rPr b="1"/>
+              <a:t>Abstract:</a:t>
+            </a:r>
+            <a:r>
+              <a:rPr/>
+              <a:t> &gt; Multi-agent systems built on large language models (LLMs) are difficult to reason about. Coordination errors such as deadlocks or type-mismatched messages are often hard to detect through testing. We introduce a domain-specific language for specifying agent coordination based on message sequence charts (MSCs). The language separates message-passing structure from LLM actions, whose outputs remain unpredictable. We define the syntax and semantics of the language and present a syntax-directed projection that generates deadlock-free local agent programs from global coordination specifications. We illustrate the approach with a diagnosis consensus protocol and show how coordination properties can be established independently of LLM nondeterminism. We also describe a runtime planning extension in which an LLM dynamically generates a coordination workflow for which the same structural guarantees apply.</a:t>
+            </a:r>
+          </a:p>
+          <a:p>
+            <a:pPr lvl="0" indent="0" marL="0">
+              <a:buNone/>
+            </a:pPr>
+            <a:r>
+              <a:rPr b="1"/>
+              <a:t>Why I recommend this paper:</a:t>
+            </a:r>
+            <a:r>
+              <a:rPr/>
+              <a:t> This is the </a:t>
+            </a:r>
+            <a:r>
+              <a:rPr b="1"/>
+              <a:t>closest existing work to the MPST vision</a:t>
+            </a:r>
+            <a:r>
+              <a:rPr/>
+              <a:t> for multi-agent governance. It provides a formal DSL for specifying multi-agent coordination, with </a:t>
+            </a:r>
+            <a:r>
+              <a:rPr b="1"/>
+              <a:t>syntax-directed projection</a:t>
+            </a:r>
+            <a:r>
+              <a:rPr/>
+              <a:t> that generates </a:t>
+            </a:r>
+            <a:r>
+              <a:rPr b="1"/>
+              <a:t>deadlock-free local programs</a:t>
+            </a:r>
+            <a:r>
+              <a:rPr/>
+              <a:t> from global specifications. The key insight: the coordination structure (message passing) is deterministic and formally verifiable, while LLM actions remain opaque and stochastic. This exactly matches the user’s intuition about separating deterministic protocol enforcement from probabilistic LLM behavior.</a:t>
+            </a:r>
+          </a:p>
+          <a:p>
+            <a:pPr lvl="0" indent="0" marL="0">
+              <a:buNone/>
+            </a:pPr>
+            <a:r>
+              <a:rPr b="1"/>
+              <a:t>Relevance to our topic:</a:t>
+            </a:r>
+            <a:r>
+              <a:rPr/>
+              <a:t> </a:t>
+            </a:r>
+            <a:r>
+              <a:rPr b="1"/>
+              <a:t>Cross-layer (Layer 0 + Layer 1)</a:t>
+            </a:r>
+            <a:r>
+              <a:rPr/>
+              <a:t> — This paper bridges specification and runtime: - </a:t>
+            </a:r>
+            <a:r>
+              <a:rPr b="1"/>
+              <a:t>Layer 0 (Spec):</a:t>
+            </a:r>
+            <a:r>
+              <a:rPr/>
+              <a:t> Global workflows are specified in a formal DSL with MSC semantics, enabling static verification of coordination properties before deployment. - </a:t>
+            </a:r>
+            <a:r>
+              <a:rPr b="1"/>
+              <a:t>Layer 1 (Runtime):</a:t>
+            </a:r>
+            <a:r>
+              <a:rPr/>
+              <a:t> The projection generates local agent programs that are </a:t>
+            </a:r>
+            <a:r>
+              <a:rPr b="1"/>
+              <a:t>guaranteed deadlock-free</a:t>
+            </a:r>
+            <a:r>
+              <a:rPr/>
+              <a:t> by construction. The runtime enforces the message-passing structure deterministically, independent of LLM nondeterminism. - </a:t>
+            </a:r>
+            <a:r>
+              <a:rPr b="1"/>
+              <a:t>MPST connection:</a:t>
+            </a:r>
+            <a:r>
+              <a:rPr/>
+              <a:t> The paper explicitly cites multiparty session types (MPSTs) as related work and positions itself as a structured-program alternative to automata-based approaches. The projection is always defined (no well-formedness conditions needed), which is a practical advantage over standard MPST.</a:t>
+            </a:r>
+          </a:p>
+          <a:p>
+            <a:pPr lvl="0" indent="0" marL="0">
+              <a:buNone/>
+            </a:pPr>
+            <a:r>
+              <a:rPr b="1"/>
+              <a:t>Key technical contributions:</a:t>
+            </a:r>
+            <a:r>
+              <a:rPr/>
+              <a:t> 1. </a:t>
+            </a:r>
+            <a:r>
+              <a:rPr b="1"/>
+              <a:t>Syntax-directed projection:</a:t>
+            </a:r>
+            <a:r>
+              <a:rPr/>
+              <a:t> No automaton construction; projection is a structural recursion on the global workflow, with correctness proof by structural induction. 2. </a:t>
+            </a:r>
+            <a:r>
+              <a:rPr b="1"/>
+              <a:t>Owned control flow:</a:t>
+            </a:r>
+            <a:r>
+              <a:rPr/>
+              <a:t> Every conditional and loop has an explicit decider lifeline, eliminating the need for MPST-style branch-mergeability conditions. 3. </a:t>
+            </a:r>
+            <a:r>
+              <a:rPr b="1"/>
+              <a:t>Control broadcasts:</a:t>
+            </a:r>
+            <a:r>
+              <a:rPr/>
+              <a:t> The projection automatically inserts explicit control messages to inform non-owner lifelines of branch choices, ensuring all agents maintain consistent local state. 4. </a:t>
+            </a:r>
+            <a:r>
+              <a:rPr b="1"/>
+              <a:t>Runtime planning extension:</a:t>
+            </a:r>
+            <a:r>
+              <a:rPr/>
+              <a:t> An LLM can dynamically generate a coordination workflow at runtime; the same structural guarantees apply because the planner only needs to produce syntactically valid global workflows.</a:t>
+            </a:r>
+          </a:p>
+          <a:p>
+            <a:pPr lvl="0" indent="0" marL="0">
+              <a:buNone/>
+            </a:pPr>
+            <a:r>
+              <a:rPr b="1"/>
+              <a:t>Which layer:</a:t>
+            </a:r>
+            <a:r>
+              <a:rPr/>
+              <a:t> </a:t>
+            </a:r>
+            <a:r>
+              <a:rPr b="1"/>
+              <a:t>Cross-layer — Layer 0 (Spec-Level) + Layer 1 (Runtime-Level)</a:t>
+            </a:r>
+          </a:p>
+          <a:p>
+            <a:pPr lvl="0" indent="0" marL="0">
+              <a:buNone/>
+            </a:pPr>
+            <a:r>
+              <a:rPr b="1"/>
+              <a:t>Is it a solution we’re looking into?</a:t>
+            </a:r>
+            <a:r>
+              <a:rPr/>
+              <a:t> Yes. This is the most direct precedent for the MPST-style multi-agent governance the user has been asking about. It demonstrates that formal coordination specifications for LLM agents are feasible, with open-source implementation (ZipperGen). The limitation: it handles coordination structure but does not verify the content of LLM actions (which remain opaque). This suggests a two-layer approach: ZipperGen for deterministic coordination + ABC/ACP for runtime behavioral enforcement.</a:t>
+            </a:r>
+          </a:p>
+          <a:p>
+            <a:pPr lvl="0" indent="0" marL="0">
+              <a:buNone/>
+            </a:pPr>
+            <a:r>
+              <a:rPr b="1"/>
+              <a:t>Recommendation reason:</a:t>
+            </a:r>
+            <a:r>
+              <a:rPr/>
+              <a:t> This paper proves that the MPST vision is not hypothetical — it has been implemented. The combination of formal global specifications + guaranteed deadlock-free local programs + runtime workflow generation is exactly the architecture needed for trustworthy multi-agent systems. It should be the reference implementation for any multi-agent governance framework.</a:t>
             </a:r>
           </a:p>
         </p:txBody>
@@ -8495,7 +8662,19 @@
             </a:pPr>
             <a:r>
               <a:rPr b="1"/>
-              <a:t>SkillFortify (Open Source)</a:t>
+              <a:t>New Products &amp; Frameworks (June 5, 2026)</a:t>
+            </a:r>
+          </a:p>
+          <a:p>
+            <a:pPr lvl="0" indent="0" marL="0">
+              <a:spcBef>
+                <a:spcPts val="3000"/>
+              </a:spcBef>
+              <a:buNone/>
+            </a:pPr>
+            <a:r>
+              <a:rPr b="1"/>
+              <a:t>AgentAssert</a:t>
             </a:r>
           </a:p>
           <a:p>
@@ -8506,35 +8685,29 @@
             </a:r>
             <a:r>
               <a:rPr/>
-              <a:t> Formal verification framework for skill supply chains</a:t>
-            </a:r>
-          </a:p>
-          <a:p>
-            <a:pPr lvl="0"/>
-            <a:r>
-              <a:rPr b="1"/>
-              <a:t>Install:</a:t>
-            </a:r>
-            <a:r>
-              <a:rPr/>
-              <a:t> </a:t>
-            </a:r>
-            <a:r>
-              <a:rPr>
-                <a:latin typeface="Courier"/>
-              </a:rPr>
-              <a:t>pip install skillfortify</a:t>
-            </a:r>
-          </a:p>
-          <a:p>
-            <a:pPr lvl="0"/>
-            <a:r>
-              <a:rPr b="1"/>
-              <a:t>GitHub:</a:t>
-            </a:r>
-            <a:r>
-              <a:rPr/>
-              <a:t> https://github.com/varun369/skillfortify</a:t>
+              <a:t> Runtime enforcement library</a:t>
+            </a:r>
+          </a:p>
+          <a:p>
+            <a:pPr lvl="0"/>
+            <a:r>
+              <a:rPr b="1"/>
+              <a:t>Source:</a:t>
+            </a:r>
+            <a:r>
+              <a:rPr/>
+              <a:t> Agent Behavioral Contracts (ABC) paper implementation</a:t>
+            </a:r>
+          </a:p>
+          <a:p>
+            <a:pPr lvl="0"/>
+            <a:r>
+              <a:rPr b="1"/>
+              <a:t>URL:</a:t>
+            </a:r>
+            <a:r>
+              <a:rPr/>
+              <a:t> https://agentassert.com/research/</a:t>
             </a:r>
           </a:p>
           <a:p>
@@ -8545,7 +8718,18 @@
             </a:r>
             <a:r>
               <a:rPr/>
-              <a:t> F1=96.95%, 0% false positives on 540 skills; SAT resolution &lt;100 ms for 1,000-node graphs</a:t>
+              <a:t> &lt;10 ms per action overhead</a:t>
+            </a:r>
+          </a:p>
+          <a:p>
+            <a:pPr lvl="0"/>
+            <a:r>
+              <a:rPr b="1"/>
+              <a:t>Capability:</a:t>
+            </a:r>
+            <a:r>
+              <a:rPr/>
+              <a:t> Detects 5.2-6.8 soft violations per session; 88-100% hard constraint compliance; behavioral drift bounded to D* &lt; 0.27</a:t>
             </a:r>
           </a:p>
           <a:p>
@@ -8556,7 +8740,7 @@
             </a:r>
             <a:r>
               <a:rPr/>
-              <a:t> MIT</a:t>
+              <a:t> Open source (Qualixar suite)</a:t>
             </a:r>
           </a:p>
           <a:p>
@@ -8569,7 +8753,7 @@
             </a:r>
             <a:r>
               <a:rPr/>
-              <a:t> The first formal (not heuristic) skill security scanner. Replaces “no findings does not mean no risk” with mathematical guarantees. Critical for CI/CD pipelines where false positives destroy developer trust.</a:t>
+              <a:t> AgentAssert is the runtime implementation of ABC contracts. It turns formal specifications into executable enforcement. The &lt;10 ms overhead means zero perceptible latency in production.</a:t>
             </a:r>
           </a:p>
         </p:txBody>
@@ -8619,7 +8803,7 @@
             </a:pPr>
             <a:r>
               <a:rPr b="1"/>
-              <a:t>AgentAssay (Open Source)</a:t>
+              <a:t>SkillFortify (Open Source)</a:t>
             </a:r>
           </a:p>
           <a:p>
@@ -8630,7 +8814,7 @@
             </a:r>
             <a:r>
               <a:rPr/>
-              <a:t> Token-efficient regression testing for agent workflows</a:t>
+              <a:t> Formal verification framework for skill supply chains</a:t>
             </a:r>
           </a:p>
           <a:p>
@@ -8647,7 +8831,7 @@
               <a:rPr>
                 <a:latin typeface="Courier"/>
               </a:rPr>
-              <a:t>pip install agentassay</a:t>
+              <a:t>pip install skillfortify</a:t>
             </a:r>
           </a:p>
           <a:p>
@@ -8658,7 +8842,7 @@
             </a:r>
             <a:r>
               <a:rPr/>
-              <a:t> https://github.com/qualixar/agentassay</a:t>
+              <a:t> https://github.com/varun369/skillfortify</a:t>
             </a:r>
           </a:p>
           <a:p>
@@ -8669,7 +8853,7 @@
             </a:r>
             <a:r>
               <a:rPr/>
-              <a:t> 78-100% cost reduction vs fixed-trial testing; 86% regression detection where binary tests have 0%</a:t>
+              <a:t> F1=96.95%, 0% false positives on 540 skills; SAT resolution &lt;100 ms for 1,000-node graphs</a:t>
             </a:r>
           </a:p>
           <a:p>
@@ -8680,7 +8864,7 @@
             </a:r>
             <a:r>
               <a:rPr/>
-              <a:t> Open source</a:t>
+              <a:t> MIT</a:t>
             </a:r>
           </a:p>
           <a:p>
@@ -8693,7 +8877,7 @@
             </a:r>
             <a:r>
               <a:rPr/>
-              <a:t> The first principled regression testing framework for non-deterministic agents. Enables CI/CD governance: “did this update break safety properties?” With pytest integration, it fits existing developer workflows.</a:t>
+              <a:t> The first formal (not heuristic) skill security scanner. Replaces “no findings does not mean no risk” with mathematical guarantees. Critical for CI/CD pipelines where false positives destroy developer trust.</a:t>
             </a:r>
           </a:p>
         </p:txBody>
@@ -8743,7 +8927,7 @@
             </a:pPr>
             <a:r>
               <a:rPr b="1"/>
-              <a:t>Agent Control Protocol (ACP)</a:t>
+              <a:t>AgentAssay (Open Source)</a:t>
             </a:r>
           </a:p>
           <a:p>
@@ -8754,18 +8938,35 @@
             </a:r>
             <a:r>
               <a:rPr/>
-              <a:t> Temporal admission control protocol with formal verification</a:t>
-            </a:r>
-          </a:p>
-          <a:p>
-            <a:pPr lvl="0"/>
-            <a:r>
-              <a:rPr b="1"/>
-              <a:t>Implementation:</a:t>
-            </a:r>
-            <a:r>
-              <a:rPr/>
-              <a:t> Go (23 packages), 138 conformance test vectors</a:t>
+              <a:t> Token-efficient regression testing for agent workflows</a:t>
+            </a:r>
+          </a:p>
+          <a:p>
+            <a:pPr lvl="0"/>
+            <a:r>
+              <a:rPr b="1"/>
+              <a:t>Install:</a:t>
+            </a:r>
+            <a:r>
+              <a:rPr/>
+              <a:t> </a:t>
+            </a:r>
+            <a:r>
+              <a:rPr>
+                <a:latin typeface="Courier"/>
+              </a:rPr>
+              <a:t>pip install agentassay</a:t>
+            </a:r>
+          </a:p>
+          <a:p>
+            <a:pPr lvl="0"/>
+            <a:r>
+              <a:rPr b="1"/>
+              <a:t>GitHub:</a:t>
+            </a:r>
+            <a:r>
+              <a:rPr/>
+              <a:t> https://github.com/qualixar/agentassay</a:t>
             </a:r>
           </a:p>
           <a:p>
@@ -8776,29 +8977,18 @@
             </a:r>
             <a:r>
               <a:rPr/>
-              <a:t> 1,720,000 req/s; 739-832 ns decision latency</a:t>
-            </a:r>
-          </a:p>
-          <a:p>
-            <a:pPr lvl="0"/>
-            <a:r>
-              <a:rPr b="1"/>
-              <a:t>Verification:</a:t>
-            </a:r>
-            <a:r>
-              <a:rPr/>
-              <a:t> TLA+ across 4,294,930,695 states, 0 violations</a:t>
-            </a:r>
-          </a:p>
-          <a:p>
-            <a:pPr lvl="0"/>
-            <a:r>
-              <a:rPr b="1"/>
-              <a:t>URL:</a:t>
-            </a:r>
-            <a:r>
-              <a:rPr/>
-              <a:t> https://github.com/topics/agent-control-protocol</a:t>
+              <a:t> 78-100% cost reduction vs fixed-trial testing; 86% regression detection where binary tests have 0%</a:t>
+            </a:r>
+          </a:p>
+          <a:p>
+            <a:pPr lvl="0"/>
+            <a:r>
+              <a:rPr b="1"/>
+              <a:t>License:</a:t>
+            </a:r>
+            <a:r>
+              <a:rPr/>
+              <a:t> Open source</a:t>
             </a:r>
           </a:p>
           <a:p>
@@ -8811,7 +9001,7 @@
             </a:r>
             <a:r>
               <a:rPr/>
-              <a:t> Production-ready admission control with mathematical proof of safety and liveness. The 6-paper Agent Governance Series provides the theoretical foundation; ACP is the operational implementation.</a:t>
+              <a:t> The first principled regression testing framework for non-deterministic agents. Enables CI/CD governance: “did this update break safety properties?” With pytest integration, it fits existing developer workflows.</a:t>
             </a:r>
           </a:p>
         </p:txBody>
@@ -8861,7 +9051,7 @@
             </a:pPr>
             <a:r>
               <a:rPr b="1"/>
-              <a:t>SkillsVote</a:t>
+              <a:t>Agent Control Protocol (ACP)</a:t>
             </a:r>
           </a:p>
           <a:p>
@@ -8872,29 +9062,51 @@
             </a:r>
             <a:r>
               <a:rPr/>
-              <a:t> Skills engine for AI agents</a:t>
-            </a:r>
-          </a:p>
-          <a:p>
-            <a:pPr lvl="0"/>
-            <a:r>
-              <a:rPr b="1"/>
-              <a:t>Reference:</a:t>
-            </a:r>
-            <a:r>
-              <a:rPr/>
-              <a:t> Comprehensive Survey on Agent Skills (arXiv:2605.07358)</a:t>
-            </a:r>
-          </a:p>
-          <a:p>
-            <a:pPr lvl="0"/>
-            <a:r>
-              <a:rPr b="1"/>
-              <a:t>Status:</a:t>
-            </a:r>
-            <a:r>
-              <a:rPr/>
-              <a:t> Mentioned as ecosystem resource</a:t>
+              <a:t> Temporal admission control protocol with formal verification</a:t>
+            </a:r>
+          </a:p>
+          <a:p>
+            <a:pPr lvl="0"/>
+            <a:r>
+              <a:rPr b="1"/>
+              <a:t>Implementation:</a:t>
+            </a:r>
+            <a:r>
+              <a:rPr/>
+              <a:t> Go (23 packages), 138 conformance test vectors</a:t>
+            </a:r>
+          </a:p>
+          <a:p>
+            <a:pPr lvl="0"/>
+            <a:r>
+              <a:rPr b="1"/>
+              <a:t>Performance:</a:t>
+            </a:r>
+            <a:r>
+              <a:rPr/>
+              <a:t> 1,720,000 req/s; 739-832 ns decision latency</a:t>
+            </a:r>
+          </a:p>
+          <a:p>
+            <a:pPr lvl="0"/>
+            <a:r>
+              <a:rPr b="1"/>
+              <a:t>Verification:</a:t>
+            </a:r>
+            <a:r>
+              <a:rPr/>
+              <a:t> TLA+ across 4,294,930,695 states, 0 violations</a:t>
+            </a:r>
+          </a:p>
+          <a:p>
+            <a:pPr lvl="0"/>
+            <a:r>
+              <a:rPr b="1"/>
+              <a:t>URL:</a:t>
+            </a:r>
+            <a:r>
+              <a:rPr/>
+              <a:t> https://github.com/topics/agent-control-protocol</a:t>
             </a:r>
           </a:p>
           <a:p>
@@ -8907,7 +9119,7 @@
             </a:r>
             <a:r>
               <a:rPr/>
-              <a:t> Part of the emerging skill routing and governance infrastructure. SkillsVote and similar engines will become the distribution layer where governance policies are enforced.</a:t>
+              <a:t> Production-ready admission control with mathematical proof of safety and liveness. The 6-paper Agent Governance Series provides the theoretical foundation; ACP is the operational implementation.</a:t>
             </a:r>
           </a:p>
         </p:txBody>
@@ -8957,264 +9169,53 @@
             </a:pPr>
             <a:r>
               <a:rPr b="1"/>
-              <a:t>Updated Implementation Roadmap</a:t>
-            </a:r>
-          </a:p>
-          <a:p>
-            <a:pPr lvl="0" indent="0" marL="0">
-              <a:spcBef>
-                <a:spcPts val="3000"/>
-              </a:spcBef>
-              <a:buNone/>
-            </a:pPr>
-            <a:r>
-              <a:rPr b="1"/>
-              <a:t>Immediate (30 days)</a:t>
-            </a:r>
-          </a:p>
-          <a:p>
-            <a:pPr lvl="0" indent="-342900" marL="342900">
-              <a:buAutoNum type="arabicPeriod"/>
-            </a:pPr>
-            <a:r>
-              <a:rPr b="1"/>
-              <a:t>Adopt GovernSpec’s 12 contract sections</a:t>
-            </a:r>
-            <a:r>
-              <a:rPr/>
-              <a:t> for all skill specifications</a:t>
-            </a:r>
-          </a:p>
-          <a:p>
-            <a:pPr lvl="0" indent="-342900" marL="342900">
-              <a:buAutoNum type="arabicPeriod"/>
-            </a:pPr>
-            <a:r>
-              <a:rPr b="1"/>
-              <a:t>Deploy Skilldex</a:t>
-            </a:r>
-            <a:r>
-              <a:rPr/>
-              <a:t> for validation — check 100% of skill packages</a:t>
-            </a:r>
-          </a:p>
-          <a:p>
-            <a:pPr lvl="0" indent="-342900" marL="342900">
-              <a:buAutoNum type="arabicPeriod"/>
-            </a:pPr>
-            <a:r>
-              <a:rPr b="1"/>
-              <a:t>Map existing skills to OWASP Top 10</a:t>
-            </a:r>
-            <a:r>
-              <a:rPr/>
-              <a:t> — identify which risks are unaddressed</a:t>
-            </a:r>
-          </a:p>
-          <a:p>
-            <a:pPr lvl="0" indent="-342900" marL="342900">
-              <a:buAutoNum type="arabicPeriod"/>
-            </a:pPr>
-            <a:r>
-              <a:rPr b="1"/>
-              <a:t>NEW: Integrate SkillFortify</a:t>
-            </a:r>
-            <a:r>
-              <a:rPr/>
-              <a:t> into CI/CD for formal skill supply chain verification</a:t>
-            </a:r>
-          </a:p>
-          <a:p>
-            <a:pPr lvl="0" indent="-342900" marL="342900">
-              <a:buAutoNum type="arabicPeriod"/>
-            </a:pPr>
-            <a:r>
-              <a:rPr b="1"/>
-              <a:t>NEW: Adopt ABC contract structure</a:t>
-            </a:r>
-            <a:r>
-              <a:rPr/>
-              <a:t> (P, I, G, R) for all agent specifications</a:t>
-            </a:r>
-          </a:p>
-          <a:p>
-            <a:pPr lvl="0" indent="0" marL="0">
-              <a:spcBef>
-                <a:spcPts val="3000"/>
-              </a:spcBef>
-              <a:buNone/>
-            </a:pPr>
-            <a:r>
-              <a:rPr b="1"/>
-              <a:t>Short-term (90 days)</a:t>
-            </a:r>
-          </a:p>
-          <a:p>
-            <a:pPr lvl="0" indent="-342900" marL="342900">
-              <a:buAutoNum startAt="6" type="arabicPeriod"/>
-            </a:pPr>
-            <a:r>
-              <a:rPr b="1"/>
-              <a:t>Implement LGA Layer 1</a:t>
-            </a:r>
-            <a:r>
-              <a:rPr/>
-              <a:t> (sandboxing) for all agent execution</a:t>
-            </a:r>
-          </a:p>
-          <a:p>
-            <a:pPr lvl="0" indent="-342900" marL="342900">
-              <a:buAutoNum startAt="6" type="arabicPeriod"/>
-            </a:pPr>
-            <a:r>
-              <a:rPr b="1"/>
-              <a:t>Deploy ST-WebAgentBench</a:t>
-            </a:r>
-            <a:r>
-              <a:rPr/>
-              <a:t> for web agent evaluation</a:t>
-            </a:r>
-          </a:p>
-          <a:p>
-            <a:pPr lvl="0" indent="-342900" marL="342900">
-              <a:buAutoNum startAt="6" type="arabicPeriod"/>
-            </a:pPr>
-            <a:r>
-              <a:rPr b="1"/>
-              <a:t>Establish baseline</a:t>
-            </a:r>
-            <a:r>
-              <a:rPr/>
-              <a:t> with BeSafe-Bench on current agents</a:t>
-            </a:r>
-          </a:p>
-          <a:p>
-            <a:pPr lvl="0" indent="-342900" marL="342900">
-              <a:buAutoNum startAt="6" type="arabicPeriod"/>
-            </a:pPr>
-            <a:r>
-              <a:rPr b="1"/>
-              <a:t>NEW: Deploy AgentAssert</a:t>
-            </a:r>
-            <a:r>
-              <a:rPr/>
-              <a:t> for runtime contract enforcement on critical agents</a:t>
-            </a:r>
-          </a:p>
-          <a:p>
-            <a:pPr lvl="0" indent="-342900" marL="342900">
-              <a:buAutoNum startAt="6" type="arabicPeriod"/>
-            </a:pPr>
-            <a:r>
-              <a:rPr b="1"/>
-              <a:t>NEW: Implement ACP-style temporal admission control</a:t>
-            </a:r>
-            <a:r>
-              <a:rPr/>
-              <a:t> for high-throughput agent services</a:t>
-            </a:r>
-          </a:p>
-          <a:p>
-            <a:pPr lvl="0" indent="-342900" marL="342900">
-              <a:buAutoNum startAt="6" type="arabicPeriod"/>
-            </a:pPr>
-            <a:r>
-              <a:rPr b="1"/>
-              <a:t>NEW: Integrate AgentAssay</a:t>
-            </a:r>
-            <a:r>
-              <a:rPr/>
-              <a:t> into CI/CD for regression testing of safety properties</a:t>
-            </a:r>
-          </a:p>
-          <a:p>
-            <a:pPr lvl="0" indent="0" marL="0">
-              <a:spcBef>
-                <a:spcPts val="3000"/>
-              </a:spcBef>
-              <a:buNone/>
-            </a:pPr>
-            <a:r>
-              <a:rPr b="1"/>
-              <a:t>Strategic (12 months)</a:t>
-            </a:r>
-          </a:p>
-          <a:p>
-            <a:pPr lvl="0" indent="-342900" marL="342900">
-              <a:buAutoNum startAt="12" type="arabicPeriod"/>
-            </a:pPr>
-            <a:r>
-              <a:rPr b="1"/>
-              <a:t>Full LGA stack</a:t>
-            </a:r>
-            <a:r>
-              <a:rPr/>
-              <a:t> — all four layers operational</a:t>
-            </a:r>
-          </a:p>
-          <a:p>
-            <a:pPr lvl="0" indent="-342900" marL="342900">
-              <a:buAutoNum startAt="12" type="arabicPeriod"/>
-            </a:pPr>
-            <a:r>
-              <a:rPr b="1"/>
-              <a:t>Microsoft-style governance toolkit</a:t>
-            </a:r>
-            <a:r>
-              <a:rPr/>
-              <a:t> — registration, policy, audit, evaluation, human-in-the-loop</a:t>
-            </a:r>
-          </a:p>
-          <a:p>
-            <a:pPr lvl="0" indent="-342900" marL="342900">
-              <a:buAutoNum startAt="12" type="arabicPeriod"/>
-            </a:pPr>
-            <a:r>
-              <a:rPr b="1"/>
-              <a:t>Continuous evaluation</a:t>
-            </a:r>
-            <a:r>
-              <a:rPr/>
-              <a:t> — weekly safety benchmarks with automated reporting</a:t>
-            </a:r>
-          </a:p>
-          <a:p>
-            <a:pPr lvl="0" indent="-342900" marL="342900">
-              <a:buAutoNum startAt="12" type="arabicPeriod"/>
-            </a:pPr>
-            <a:r>
-              <a:rPr b="1"/>
-              <a:t>NEW: Implement skill-level attestation</a:t>
-            </a:r>
-            <a:r>
-              <a:rPr/>
-              <a:t> (per MIGT) binding skill execution to verified machine identity</a:t>
-            </a:r>
-          </a:p>
-          <a:p>
-            <a:pPr lvl="0" indent="-342900" marL="342900">
-              <a:buAutoNum startAt="12" type="arabicPeriod"/>
-            </a:pPr>
-            <a:r>
-              <a:rPr b="1"/>
-              <a:t>NEW: Adopt Agent Governance Series</a:t>
-            </a:r>
-            <a:r>
-              <a:rPr/>
-              <a:t> (6 papers) as the formal foundation for all governance architecture</a:t>
-            </a:r>
-          </a:p>
-          <a:p>
-            <a:pPr lvl="0" indent="-342900" marL="342900">
-              <a:buAutoNum startAt="12" type="arabicPeriod"/>
-            </a:pPr>
-            <a:r>
-              <a:rPr b="1"/>
-              <a:t>NEW: Build benchmark consistency dashboard</a:t>
-            </a:r>
-            <a:r>
-              <a:rPr/>
-              <a:t> using Taxonomy and Consistency Analysis framework — never trust a single benchmark</a:t>
+              <a:t>SkillsVote</a:t>
+            </a:r>
+          </a:p>
+          <a:p>
+            <a:pPr lvl="0"/>
+            <a:r>
+              <a:rPr b="1"/>
+              <a:t>Type:</a:t>
+            </a:r>
+            <a:r>
+              <a:rPr/>
+              <a:t> Skills engine for AI agents</a:t>
+            </a:r>
+          </a:p>
+          <a:p>
+            <a:pPr lvl="0"/>
+            <a:r>
+              <a:rPr b="1"/>
+              <a:t>Reference:</a:t>
+            </a:r>
+            <a:r>
+              <a:rPr/>
+              <a:t> Comprehensive Survey on Agent Skills (arXiv:2605.07358)</a:t>
+            </a:r>
+          </a:p>
+          <a:p>
+            <a:pPr lvl="0"/>
+            <a:r>
+              <a:rPr b="1"/>
+              <a:t>Status:</a:t>
+            </a:r>
+            <a:r>
+              <a:rPr/>
+              <a:t> Mentioned as ecosystem resource</a:t>
+            </a:r>
+          </a:p>
+          <a:p>
+            <a:pPr lvl="0" indent="0" marL="0">
+              <a:buNone/>
+            </a:pPr>
+            <a:r>
+              <a:rPr b="1"/>
+              <a:t>Why it matters:</a:t>
+            </a:r>
+            <a:r>
+              <a:rPr/>
+              <a:t> Part of the emerging skill routing and governance infrastructure. SkillsVote and similar engines will become the distribution layer where governance policies are enforced.</a:t>
             </a:r>
           </a:p>
         </p:txBody>
@@ -9264,58 +9265,264 @@
             </a:pPr>
             <a:r>
               <a:rPr b="1"/>
-              <a:t>Why This Matters (Updated)</a:t>
-            </a:r>
-          </a:p>
-          <a:p>
-            <a:pPr lvl="0" indent="0" marL="0">
-              <a:buNone/>
-            </a:pPr>
-            <a:r>
-              <a:rPr b="1"/>
-              <a:t>The data is clear:</a:t>
-            </a:r>
-            <a:r>
-              <a:rPr/>
-              <a:t> - 34% of community skill packages are malformed (Skilldex) - 89% of attacks succeed against baseline guardrails (LGA) - 60%+ of tasks have safety violations (BeSafe-Bench) - 40% of agent projects face cancellation (Agent Evaluation Guide) - 73% incident reduction with governance toolkit (Microsoft) - </a:t>
-            </a:r>
-            <a:r>
-              <a:rPr b="1"/>
-              <a:t>NEW: 0% concordance across safety benchmarks (Kendall’s W = 0.10) — benchmark scores are mostly noise</a:t>
-            </a:r>
-            <a:r>
-              <a:rPr/>
-              <a:t> - </a:t>
-            </a:r>
-            <a:r>
-              <a:rPr b="1"/>
-              <a:t>NEW: 100% of individually-valid requests in a 500-request attack chain approved by stateless engines — temporal governance is essential</a:t>
-            </a:r>
-            <a:r>
-              <a:rPr/>
-              <a:t> - </a:t>
-            </a:r>
-            <a:r>
-              <a:rPr b="1"/>
-              <a:t>NEW: 1,200+ malicious skills infiltrated OpenClaw marketplace (ClawHavoc) — heuristic scanning is insufficient</a:t>
-            </a:r>
-          </a:p>
-          <a:p>
-            <a:pPr lvl="0" indent="0" marL="0">
-              <a:buNone/>
-            </a:pPr>
-            <a:r>
-              <a:rPr b="1"/>
-              <a:t>Governance is not optional. It’s the difference between agents that work and agents that are safe to use.</a:t>
-            </a:r>
-          </a:p>
-          <a:p>
-            <a:pPr lvl="0" indent="0" marL="0">
-              <a:buNone/>
-            </a:pPr>
-            <a:r>
-              <a:rPr b="1"/>
-              <a:t>The shift from heuristic to formal guarantees is accelerating. ABC, AgentVerify, SkillFortify, and ACP provide mathematically grounded governance mechanisms. The question is no longer “should we govern agents?” but “which formal framework should we adopt first?”</a:t>
+              <a:t>Updated Implementation Roadmap</a:t>
+            </a:r>
+          </a:p>
+          <a:p>
+            <a:pPr lvl="0" indent="0" marL="0">
+              <a:spcBef>
+                <a:spcPts val="3000"/>
+              </a:spcBef>
+              <a:buNone/>
+            </a:pPr>
+            <a:r>
+              <a:rPr b="1"/>
+              <a:t>Immediate (30 days)</a:t>
+            </a:r>
+          </a:p>
+          <a:p>
+            <a:pPr lvl="0" indent="-342900" marL="342900">
+              <a:buAutoNum type="arabicPeriod"/>
+            </a:pPr>
+            <a:r>
+              <a:rPr b="1"/>
+              <a:t>Adopt GovernSpec’s 12 contract sections</a:t>
+            </a:r>
+            <a:r>
+              <a:rPr/>
+              <a:t> for all skill specifications</a:t>
+            </a:r>
+          </a:p>
+          <a:p>
+            <a:pPr lvl="0" indent="-342900" marL="342900">
+              <a:buAutoNum type="arabicPeriod"/>
+            </a:pPr>
+            <a:r>
+              <a:rPr b="1"/>
+              <a:t>Deploy Skilldex</a:t>
+            </a:r>
+            <a:r>
+              <a:rPr/>
+              <a:t> for validation — check 100% of skill packages</a:t>
+            </a:r>
+          </a:p>
+          <a:p>
+            <a:pPr lvl="0" indent="-342900" marL="342900">
+              <a:buAutoNum type="arabicPeriod"/>
+            </a:pPr>
+            <a:r>
+              <a:rPr b="1"/>
+              <a:t>Map existing skills to OWASP Top 10</a:t>
+            </a:r>
+            <a:r>
+              <a:rPr/>
+              <a:t> — identify which risks are unaddressed</a:t>
+            </a:r>
+          </a:p>
+          <a:p>
+            <a:pPr lvl="0" indent="-342900" marL="342900">
+              <a:buAutoNum type="arabicPeriod"/>
+            </a:pPr>
+            <a:r>
+              <a:rPr b="1"/>
+              <a:t>NEW: Integrate SkillFortify</a:t>
+            </a:r>
+            <a:r>
+              <a:rPr/>
+              <a:t> into CI/CD for formal skill supply chain verification</a:t>
+            </a:r>
+          </a:p>
+          <a:p>
+            <a:pPr lvl="0" indent="-342900" marL="342900">
+              <a:buAutoNum type="arabicPeriod"/>
+            </a:pPr>
+            <a:r>
+              <a:rPr b="1"/>
+              <a:t>NEW: Adopt ABC contract structure</a:t>
+            </a:r>
+            <a:r>
+              <a:rPr/>
+              <a:t> (P, I, G, R) for all agent specifications</a:t>
+            </a:r>
+          </a:p>
+          <a:p>
+            <a:pPr lvl="0" indent="0" marL="0">
+              <a:spcBef>
+                <a:spcPts val="3000"/>
+              </a:spcBef>
+              <a:buNone/>
+            </a:pPr>
+            <a:r>
+              <a:rPr b="1"/>
+              <a:t>Short-term (90 days)</a:t>
+            </a:r>
+          </a:p>
+          <a:p>
+            <a:pPr lvl="0" indent="-342900" marL="342900">
+              <a:buAutoNum startAt="6" type="arabicPeriod"/>
+            </a:pPr>
+            <a:r>
+              <a:rPr b="1"/>
+              <a:t>Implement LGA Layer 1</a:t>
+            </a:r>
+            <a:r>
+              <a:rPr/>
+              <a:t> (sandboxing) for all agent execution</a:t>
+            </a:r>
+          </a:p>
+          <a:p>
+            <a:pPr lvl="0" indent="-342900" marL="342900">
+              <a:buAutoNum startAt="6" type="arabicPeriod"/>
+            </a:pPr>
+            <a:r>
+              <a:rPr b="1"/>
+              <a:t>Deploy ST-WebAgentBench</a:t>
+            </a:r>
+            <a:r>
+              <a:rPr/>
+              <a:t> for web agent evaluation</a:t>
+            </a:r>
+          </a:p>
+          <a:p>
+            <a:pPr lvl="0" indent="-342900" marL="342900">
+              <a:buAutoNum startAt="6" type="arabicPeriod"/>
+            </a:pPr>
+            <a:r>
+              <a:rPr b="1"/>
+              <a:t>Establish baseline</a:t>
+            </a:r>
+            <a:r>
+              <a:rPr/>
+              <a:t> with BeSafe-Bench on current agents</a:t>
+            </a:r>
+          </a:p>
+          <a:p>
+            <a:pPr lvl="0" indent="-342900" marL="342900">
+              <a:buAutoNum startAt="6" type="arabicPeriod"/>
+            </a:pPr>
+            <a:r>
+              <a:rPr b="1"/>
+              <a:t>NEW: Deploy AgentAssert</a:t>
+            </a:r>
+            <a:r>
+              <a:rPr/>
+              <a:t> for runtime contract enforcement on critical agents</a:t>
+            </a:r>
+          </a:p>
+          <a:p>
+            <a:pPr lvl="0" indent="-342900" marL="342900">
+              <a:buAutoNum startAt="6" type="arabicPeriod"/>
+            </a:pPr>
+            <a:r>
+              <a:rPr b="1"/>
+              <a:t>NEW: Implement ACP-style temporal admission control</a:t>
+            </a:r>
+            <a:r>
+              <a:rPr/>
+              <a:t> for high-throughput agent services</a:t>
+            </a:r>
+          </a:p>
+          <a:p>
+            <a:pPr lvl="0" indent="-342900" marL="342900">
+              <a:buAutoNum startAt="6" type="arabicPeriod"/>
+            </a:pPr>
+            <a:r>
+              <a:rPr b="1"/>
+              <a:t>NEW: Integrate AgentAssay</a:t>
+            </a:r>
+            <a:r>
+              <a:rPr/>
+              <a:t> into CI/CD for regression testing of safety properties</a:t>
+            </a:r>
+          </a:p>
+          <a:p>
+            <a:pPr lvl="0" indent="0" marL="0">
+              <a:spcBef>
+                <a:spcPts val="3000"/>
+              </a:spcBef>
+              <a:buNone/>
+            </a:pPr>
+            <a:r>
+              <a:rPr b="1"/>
+              <a:t>Strategic (12 months)</a:t>
+            </a:r>
+          </a:p>
+          <a:p>
+            <a:pPr lvl="0" indent="-342900" marL="342900">
+              <a:buAutoNum startAt="12" type="arabicPeriod"/>
+            </a:pPr>
+            <a:r>
+              <a:rPr b="1"/>
+              <a:t>Full LGA stack</a:t>
+            </a:r>
+            <a:r>
+              <a:rPr/>
+              <a:t> — all four layers operational</a:t>
+            </a:r>
+          </a:p>
+          <a:p>
+            <a:pPr lvl="0" indent="-342900" marL="342900">
+              <a:buAutoNum startAt="12" type="arabicPeriod"/>
+            </a:pPr>
+            <a:r>
+              <a:rPr b="1"/>
+              <a:t>Microsoft-style governance toolkit</a:t>
+            </a:r>
+            <a:r>
+              <a:rPr/>
+              <a:t> — registration, policy, audit, evaluation, human-in-the-loop</a:t>
+            </a:r>
+          </a:p>
+          <a:p>
+            <a:pPr lvl="0" indent="-342900" marL="342900">
+              <a:buAutoNum startAt="12" type="arabicPeriod"/>
+            </a:pPr>
+            <a:r>
+              <a:rPr b="1"/>
+              <a:t>Continuous evaluation</a:t>
+            </a:r>
+            <a:r>
+              <a:rPr/>
+              <a:t> — weekly safety benchmarks with automated reporting</a:t>
+            </a:r>
+          </a:p>
+          <a:p>
+            <a:pPr lvl="0" indent="-342900" marL="342900">
+              <a:buAutoNum startAt="12" type="arabicPeriod"/>
+            </a:pPr>
+            <a:r>
+              <a:rPr b="1"/>
+              <a:t>NEW: Implement skill-level attestation</a:t>
+            </a:r>
+            <a:r>
+              <a:rPr/>
+              <a:t> (per MIGT) binding skill execution to verified machine identity</a:t>
+            </a:r>
+          </a:p>
+          <a:p>
+            <a:pPr lvl="0" indent="-342900" marL="342900">
+              <a:buAutoNum startAt="12" type="arabicPeriod"/>
+            </a:pPr>
+            <a:r>
+              <a:rPr b="1"/>
+              <a:t>NEW: Adopt Agent Governance Series</a:t>
+            </a:r>
+            <a:r>
+              <a:rPr/>
+              <a:t> (6 papers) as the formal foundation for all governance architecture</a:t>
+            </a:r>
+          </a:p>
+          <a:p>
+            <a:pPr lvl="0" indent="-342900" marL="342900">
+              <a:buAutoNum startAt="12" type="arabicPeriod"/>
+            </a:pPr>
+            <a:r>
+              <a:rPr b="1"/>
+              <a:t>NEW: Build benchmark consistency dashboard</a:t>
+            </a:r>
+            <a:r>
+              <a:rPr/>
+              <a:t> using Taxonomy and Consistency Analysis framework — never trust a single benchmark</a:t>
             </a:r>
           </a:p>
         </p:txBody>
@@ -9358,20 +9565,6 @@
           <a:lstStyle/>
           <a:p>
             <a:pPr lvl="0" indent="0" marL="0">
-              <a:buNone/>
-            </a:pPr>
-            <a:r>
-              <a:rPr i="1"/>
-              <a:t>Compiled by EvaPaper | June 5, 2026</a:t>
-            </a:r>
-            <a:br/>
-            <a:r>
-              <a:rPr i="1"/>
-              <a:t>Repo: https://github.com/ginaecho/EvaPaper</a:t>
-            </a:r>
-          </a:p>
-          <a:p>
-            <a:pPr lvl="0" indent="0" marL="0">
               <a:spcBef>
                 <a:spcPts val="3000"/>
               </a:spcBef>
@@ -9379,187 +9572,58 @@
             </a:pPr>
             <a:r>
               <a:rPr b="1"/>
-              <a:t>Layer 0: Spec-Level Governance</a:t>
-            </a:r>
-          </a:p>
-          <a:p>
-            <a:pPr lvl="0" indent="0" marL="0">
-              <a:buNone/>
-            </a:pPr>
-            <a:r>
-              <a:rPr b="1"/>
-              <a:t>Goal:</a:t>
-            </a:r>
-            <a:r>
-              <a:rPr/>
-              <a:t> Ensure every skill specification is correct, complete, and safe before it ever reaches an agent.</a:t>
-            </a:r>
-          </a:p>
-          <a:p>
-            <a:pPr lvl="0" indent="0" marL="0">
-              <a:buNone/>
-            </a:pPr>
-            <a:r>
-              <a:rPr b="1"/>
-              <a:t>Key papers:</a:t>
-            </a:r>
-            <a:r>
-              <a:rPr/>
-              <a:t> Skilldex, GovernSpec</a:t>
-            </a:r>
-          </a:p>
-          <a:p>
-            <a:pPr lvl="0" indent="0" marL="0">
-              <a:buNone/>
-            </a:pPr>
-            <a:r>
-              <a:rPr b="1"/>
-              <a:t>Key questions:</a:t>
-            </a:r>
-            <a:r>
-              <a:rPr/>
-              <a:t> - Does the skill follow the format specification? - Are goals, boundaries, and permissions declared? - Are there coherence conflicts with other skills? - Does the skill specify verification steps and human approval points?</a:t>
-            </a:r>
-          </a:p>
-          <a:p>
-            <a:pPr lvl="0" indent="0" marL="0">
-              <a:buNone/>
-            </a:pPr>
-            <a:r>
-              <a:rPr b="1"/>
-              <a:t>Tools:</a:t>
-            </a:r>
-            <a:r>
-              <a:rPr/>
-              <a:t> - Skilldex (validation engine) - GovernSpec’s 12 contract sections</a:t>
-            </a:r>
-          </a:p>
-          <a:p>
-            <a:pPr lvl="0" indent="0" marL="0">
-              <a:spcBef>
-                <a:spcPts val="3000"/>
-              </a:spcBef>
-              <a:buNone/>
-            </a:pPr>
-            <a:r>
-              <a:rPr b="1"/>
-              <a:t>Layer 1: Runtime-Level Governance</a:t>
-            </a:r>
-          </a:p>
-          <a:p>
-            <a:pPr lvl="0" indent="0" marL="0">
-              <a:buNone/>
-            </a:pPr>
-            <a:r>
-              <a:rPr b="1"/>
-              <a:t>Goal:</a:t>
-            </a:r>
-            <a:r>
-              <a:rPr/>
-              <a:t> Ensure every agent execution is sandboxed, verified, authorized, and logged.</a:t>
-            </a:r>
-          </a:p>
-          <a:p>
-            <a:pPr lvl="0" indent="0" marL="0">
-              <a:buNone/>
-            </a:pPr>
-            <a:r>
-              <a:rPr b="1"/>
-              <a:t>Key papers:</a:t>
-            </a:r>
-            <a:r>
-              <a:rPr/>
-              <a:t> LGA, OWASP (Prompt Injection, Excessive Agency)</a:t>
-            </a:r>
-          </a:p>
-          <a:p>
-            <a:pPr lvl="0" indent="0" marL="0">
-              <a:buNone/>
-            </a:pPr>
-            <a:r>
-              <a:rPr b="1"/>
-              <a:t>Key questions:</a:t>
-            </a:r>
-            <a:r>
-              <a:rPr/>
-              <a:t> - Is the agent executing in a sandbox? - Is the intent verified before tool invocation? - Are inter-agent communications zero-trust authorized? - Is every action immutably logged?</a:t>
-            </a:r>
-          </a:p>
-          <a:p>
-            <a:pPr lvl="0" indent="0" marL="0">
-              <a:buNone/>
-            </a:pPr>
-            <a:r>
-              <a:rPr b="1"/>
-              <a:t>Tools:</a:t>
-            </a:r>
-            <a:r>
-              <a:rPr/>
-              <a:t> - LGA’s four layers (sandboxing, intent verification, zero-trust authorization, audit logging) - OWASP mitigation strategies</a:t>
-            </a:r>
-          </a:p>
-          <a:p>
-            <a:pPr lvl="0" indent="0" marL="0">
-              <a:spcBef>
-                <a:spcPts val="3000"/>
-              </a:spcBef>
-              <a:buNone/>
-            </a:pPr>
-            <a:r>
-              <a:rPr b="1"/>
-              <a:t>Layer 2: Behavioral-Level Governance</a:t>
-            </a:r>
-          </a:p>
-          <a:p>
-            <a:pPr lvl="0" indent="0" marL="0">
-              <a:buNone/>
-            </a:pPr>
-            <a:r>
-              <a:rPr b="1"/>
-              <a:t>Goal:</a:t>
-            </a:r>
-            <a:r>
-              <a:rPr/>
-              <a:t> Ensure every agent behaves safely and trustworthily in real-world tasks.</a:t>
-            </a:r>
-          </a:p>
-          <a:p>
-            <a:pPr lvl="0" indent="0" marL="0">
-              <a:buNone/>
-            </a:pPr>
-            <a:r>
-              <a:rPr b="1"/>
-              <a:t>Key papers:</a:t>
-            </a:r>
-            <a:r>
-              <a:rPr/>
-              <a:t> BeSafe-Bench, ST-WebAgentBench, Agent Evaluation Guide</a:t>
-            </a:r>
-          </a:p>
-          <a:p>
-            <a:pPr lvl="0" indent="0" marL="0">
-              <a:buNone/>
-            </a:pPr>
-            <a:r>
-              <a:rPr b="1"/>
-              <a:t>Key questions:</a:t>
-            </a:r>
-            <a:r>
-              <a:rPr/>
-              <a:t> - Does the agent complete tasks while adhering to safety constraints? - Does it violate policies under task pressure? - Can it recover from errors? - Does its reasoning align with human expectations?</a:t>
-            </a:r>
-          </a:p>
-          <a:p>
-            <a:pPr lvl="0" indent="0" marL="0">
-              <a:buNone/>
-            </a:pPr>
-            <a:r>
-              <a:rPr b="1"/>
-              <a:t>Tools:</a:t>
-            </a:r>
-            <a:r>
-              <a:rPr/>
-              <a:t> - BeSafe-Bench (functional environment testing) - ST-WebAgentBench (enterprise scenario testing) - Agent Evaluation Guide’s six dimensions</a:t>
+              <a:t>Why This Matters (Updated)</a:t>
+            </a:r>
+          </a:p>
+          <a:p>
+            <a:pPr lvl="0" indent="0" marL="0">
+              <a:buNone/>
+            </a:pPr>
+            <a:r>
+              <a:rPr b="1"/>
+              <a:t>The data is clear:</a:t>
+            </a:r>
+            <a:r>
+              <a:rPr/>
+              <a:t> - 34% of community skill packages are malformed (Skilldex) - 89% of attacks succeed against baseline guardrails (LGA) - 60%+ of tasks have safety violations (BeSafe-Bench) - 40% of agent projects face cancellation (Agent Evaluation Guide) - 73% incident reduction with governance toolkit (Microsoft) - </a:t>
+            </a:r>
+            <a:r>
+              <a:rPr b="1"/>
+              <a:t>NEW: 0% concordance across safety benchmarks (Kendall’s W = 0.10) — benchmark scores are mostly noise</a:t>
+            </a:r>
+            <a:r>
+              <a:rPr/>
+              <a:t> - </a:t>
+            </a:r>
+            <a:r>
+              <a:rPr b="1"/>
+              <a:t>NEW: 100% of individually-valid requests in a 500-request attack chain approved by stateless engines — temporal governance is essential</a:t>
+            </a:r>
+            <a:r>
+              <a:rPr/>
+              <a:t> - </a:t>
+            </a:r>
+            <a:r>
+              <a:rPr b="1"/>
+              <a:t>NEW: 1,200+ malicious skills infiltrated OpenClaw marketplace (ClawHavoc) — heuristic scanning is insufficient</a:t>
+            </a:r>
+          </a:p>
+          <a:p>
+            <a:pPr lvl="0" indent="0" marL="0">
+              <a:buNone/>
+            </a:pPr>
+            <a:r>
+              <a:rPr b="1"/>
+              <a:t>Governance is not optional. It’s the difference between agents that work and agents that are safe to use.</a:t>
+            </a:r>
+          </a:p>
+          <a:p>
+            <a:pPr lvl="0" indent="0" marL="0">
+              <a:buNone/>
+            </a:pPr>
+            <a:r>
+              <a:rPr b="1"/>
+              <a:t>The shift from heuristic to formal guarantees is accelerating. ABC, AgentVerify, SkillFortify, and ACP provide mathematically grounded governance mechanisms. The question is no longer “should we govern agents?” but “which formal framework should we adopt first?”</a:t>
             </a:r>
           </a:p>
         </p:txBody>
@@ -9602,6 +9666,20 @@
           <a:lstStyle/>
           <a:p>
             <a:pPr lvl="0" indent="0" marL="0">
+              <a:buNone/>
+            </a:pPr>
+            <a:r>
+              <a:rPr i="1"/>
+              <a:t>Compiled by EvaPaper | June 5, 2026</a:t>
+            </a:r>
+            <a:br/>
+            <a:r>
+              <a:rPr i="1"/>
+              <a:t>Repo: https://github.com/ginaecho/EvaPaper</a:t>
+            </a:r>
+          </a:p>
+          <a:p>
+            <a:pPr lvl="0" indent="0" marL="0">
               <a:spcBef>
                 <a:spcPts val="3000"/>
               </a:spcBef>
@@ -9609,7 +9687,59 @@
             </a:pPr>
             <a:r>
               <a:rPr b="1"/>
-              <a:t>Implementation Roadmap</a:t>
+              <a:t>Layer 0: Spec-Level Governance</a:t>
+            </a:r>
+          </a:p>
+          <a:p>
+            <a:pPr lvl="0" indent="0" marL="0">
+              <a:buNone/>
+            </a:pPr>
+            <a:r>
+              <a:rPr b="1"/>
+              <a:t>Goal:</a:t>
+            </a:r>
+            <a:r>
+              <a:rPr/>
+              <a:t> Ensure every skill specification is correct, complete, and safe before it ever reaches an agent.</a:t>
+            </a:r>
+          </a:p>
+          <a:p>
+            <a:pPr lvl="0" indent="0" marL="0">
+              <a:buNone/>
+            </a:pPr>
+            <a:r>
+              <a:rPr b="1"/>
+              <a:t>Key papers:</a:t>
+            </a:r>
+            <a:r>
+              <a:rPr/>
+              <a:t> Skilldex, GovernSpec</a:t>
+            </a:r>
+          </a:p>
+          <a:p>
+            <a:pPr lvl="0" indent="0" marL="0">
+              <a:buNone/>
+            </a:pPr>
+            <a:r>
+              <a:rPr b="1"/>
+              <a:t>Key questions:</a:t>
+            </a:r>
+            <a:r>
+              <a:rPr/>
+              <a:t> - Does the skill follow the format specification? - Are goals, boundaries, and permissions declared? - Are there coherence conflicts with other skills? - Does the skill specify verification steps and human approval points?</a:t>
+            </a:r>
+          </a:p>
+          <a:p>
+            <a:pPr lvl="0" indent="0" marL="0">
+              <a:buNone/>
+            </a:pPr>
+            <a:r>
+              <a:rPr b="1"/>
+              <a:t>Tools:</a:t>
+            </a:r>
+            <a:r>
+              <a:rPr/>
+              <a:t> - Skilldex (validation engine) - GovernSpec’s 12 contract sections</a:t>
             </a:r>
           </a:p>
           <a:p>
@@ -9621,46 +9751,59 @@
             </a:pPr>
             <a:r>
               <a:rPr b="1"/>
-              <a:t>Immediate (30 days)</a:t>
-            </a:r>
-          </a:p>
-          <a:p>
-            <a:pPr lvl="0" indent="-342900" marL="342900">
-              <a:buAutoNum type="arabicPeriod"/>
-            </a:pPr>
-            <a:r>
-              <a:rPr b="1"/>
-              <a:t>Adopt GovernSpec’s 12 contract sections</a:t>
-            </a:r>
-            <a:r>
-              <a:rPr/>
-              <a:t> for all skill specifications</a:t>
-            </a:r>
-          </a:p>
-          <a:p>
-            <a:pPr lvl="0" indent="-342900" marL="342900">
-              <a:buAutoNum type="arabicPeriod"/>
-            </a:pPr>
-            <a:r>
-              <a:rPr b="1"/>
-              <a:t>Deploy Skilldex</a:t>
-            </a:r>
-            <a:r>
-              <a:rPr/>
-              <a:t> for validation — check 100% of skill packages</a:t>
-            </a:r>
-          </a:p>
-          <a:p>
-            <a:pPr lvl="0" indent="-342900" marL="342900">
-              <a:buAutoNum type="arabicPeriod"/>
-            </a:pPr>
-            <a:r>
-              <a:rPr b="1"/>
-              <a:t>Map existing skills to OWASP Top 10</a:t>
-            </a:r>
-            <a:r>
-              <a:rPr/>
-              <a:t> — identify which risks are unaddressed</a:t>
+              <a:t>Layer 1: Runtime-Level Governance</a:t>
+            </a:r>
+          </a:p>
+          <a:p>
+            <a:pPr lvl="0" indent="0" marL="0">
+              <a:buNone/>
+            </a:pPr>
+            <a:r>
+              <a:rPr b="1"/>
+              <a:t>Goal:</a:t>
+            </a:r>
+            <a:r>
+              <a:rPr/>
+              <a:t> Ensure every agent execution is sandboxed, verified, authorized, and logged.</a:t>
+            </a:r>
+          </a:p>
+          <a:p>
+            <a:pPr lvl="0" indent="0" marL="0">
+              <a:buNone/>
+            </a:pPr>
+            <a:r>
+              <a:rPr b="1"/>
+              <a:t>Key papers:</a:t>
+            </a:r>
+            <a:r>
+              <a:rPr/>
+              <a:t> LGA, OWASP (Prompt Injection, Excessive Agency)</a:t>
+            </a:r>
+          </a:p>
+          <a:p>
+            <a:pPr lvl="0" indent="0" marL="0">
+              <a:buNone/>
+            </a:pPr>
+            <a:r>
+              <a:rPr b="1"/>
+              <a:t>Key questions:</a:t>
+            </a:r>
+            <a:r>
+              <a:rPr/>
+              <a:t> - Is the agent executing in a sandbox? - Is the intent verified before tool invocation? - Are inter-agent communications zero-trust authorized? - Is every action immutably logged?</a:t>
+            </a:r>
+          </a:p>
+          <a:p>
+            <a:pPr lvl="0" indent="0" marL="0">
+              <a:buNone/>
+            </a:pPr>
+            <a:r>
+              <a:rPr b="1"/>
+              <a:t>Tools:</a:t>
+            </a:r>
+            <a:r>
+              <a:rPr/>
+              <a:t> - LGA’s four layers (sandboxing, intent verification, zero-trust authorization, audit logging) - OWASP mitigation strategies</a:t>
             </a:r>
           </a:p>
           <a:p>
@@ -9672,97 +9815,59 @@
             </a:pPr>
             <a:r>
               <a:rPr b="1"/>
-              <a:t>Short-term (90 days)</a:t>
-            </a:r>
-          </a:p>
-          <a:p>
-            <a:pPr lvl="0" indent="-342900" marL="342900">
-              <a:buAutoNum startAt="4" type="arabicPeriod"/>
-            </a:pPr>
-            <a:r>
-              <a:rPr b="1"/>
-              <a:t>Implement LGA Layer 1</a:t>
-            </a:r>
-            <a:r>
-              <a:rPr/>
-              <a:t> (sandboxing) for all agent execution</a:t>
-            </a:r>
-          </a:p>
-          <a:p>
-            <a:pPr lvl="0" indent="-342900" marL="342900">
-              <a:buAutoNum startAt="4" type="arabicPeriod"/>
-            </a:pPr>
-            <a:r>
-              <a:rPr b="1"/>
-              <a:t>Deploy ST-WebAgentBench</a:t>
-            </a:r>
-            <a:r>
-              <a:rPr/>
-              <a:t> for web agent evaluation</a:t>
-            </a:r>
-          </a:p>
-          <a:p>
-            <a:pPr lvl="0" indent="-342900" marL="342900">
-              <a:buAutoNum startAt="4" type="arabicPeriod"/>
-            </a:pPr>
-            <a:r>
-              <a:rPr b="1"/>
-              <a:t>Establish baseline</a:t>
-            </a:r>
-            <a:r>
-              <a:rPr/>
-              <a:t> with BeSafe-Bench on current agents</a:t>
-            </a:r>
-          </a:p>
-          <a:p>
-            <a:pPr lvl="0" indent="0" marL="0">
-              <a:spcBef>
-                <a:spcPts val="3000"/>
-              </a:spcBef>
-              <a:buNone/>
-            </a:pPr>
-            <a:r>
-              <a:rPr b="1"/>
-              <a:t>Strategic (12 months)</a:t>
-            </a:r>
-          </a:p>
-          <a:p>
-            <a:pPr lvl="0" indent="-342900" marL="342900">
-              <a:buAutoNum startAt="7" type="arabicPeriod"/>
-            </a:pPr>
-            <a:r>
-              <a:rPr b="1"/>
-              <a:t>Full LGA stack</a:t>
-            </a:r>
-            <a:r>
-              <a:rPr/>
-              <a:t> — all four layers operational</a:t>
-            </a:r>
-          </a:p>
-          <a:p>
-            <a:pPr lvl="0" indent="-342900" marL="342900">
-              <a:buAutoNum startAt="7" type="arabicPeriod"/>
-            </a:pPr>
-            <a:r>
-              <a:rPr b="1"/>
-              <a:t>Microsoft-style governance toolkit</a:t>
-            </a:r>
-            <a:r>
-              <a:rPr/>
-              <a:t> — registration, policy, audit, evaluation, human-in-the-loop</a:t>
-            </a:r>
-          </a:p>
-          <a:p>
-            <a:pPr lvl="0" indent="-342900" marL="342900">
-              <a:buAutoNum startAt="7" type="arabicPeriod"/>
-            </a:pPr>
-            <a:r>
-              <a:rPr b="1"/>
-              <a:t>Continuous evaluation</a:t>
-            </a:r>
-            <a:r>
-              <a:rPr/>
-              <a:t> — weekly safety benchmarks with automated reporting</a:t>
+              <a:t>Layer 2: Behavioral-Level Governance</a:t>
+            </a:r>
+          </a:p>
+          <a:p>
+            <a:pPr lvl="0" indent="0" marL="0">
+              <a:buNone/>
+            </a:pPr>
+            <a:r>
+              <a:rPr b="1"/>
+              <a:t>Goal:</a:t>
+            </a:r>
+            <a:r>
+              <a:rPr/>
+              <a:t> Ensure every agent behaves safely and trustworthily in real-world tasks.</a:t>
+            </a:r>
+          </a:p>
+          <a:p>
+            <a:pPr lvl="0" indent="0" marL="0">
+              <a:buNone/>
+            </a:pPr>
+            <a:r>
+              <a:rPr b="1"/>
+              <a:t>Key papers:</a:t>
+            </a:r>
+            <a:r>
+              <a:rPr/>
+              <a:t> BeSafe-Bench, ST-WebAgentBench, Agent Evaluation Guide</a:t>
+            </a:r>
+          </a:p>
+          <a:p>
+            <a:pPr lvl="0" indent="0" marL="0">
+              <a:buNone/>
+            </a:pPr>
+            <a:r>
+              <a:rPr b="1"/>
+              <a:t>Key questions:</a:t>
+            </a:r>
+            <a:r>
+              <a:rPr/>
+              <a:t> - Does the agent complete tasks while adhering to safety constraints? - Does it violate policies under task pressure? - Can it recover from errors? - Does its reasoning align with human expectations?</a:t>
+            </a:r>
+          </a:p>
+          <a:p>
+            <a:pPr lvl="0" indent="0" marL="0">
+              <a:buNone/>
+            </a:pPr>
+            <a:r>
+              <a:rPr b="1"/>
+              <a:t>Tools:</a:t>
+            </a:r>
+            <a:r>
+              <a:rPr/>
+              <a:t> - BeSafe-Bench (functional environment testing) - ST-WebAgentBench (enterprise scenario testing) - Agent Evaluation Guide’s six dimensions</a:t>
             </a:r>
           </a:p>
         </p:txBody>
@@ -9812,29 +9917,160 @@
             </a:pPr>
             <a:r>
               <a:rPr b="1"/>
-              <a:t>Why This Matters</a:t>
-            </a:r>
-          </a:p>
-          <a:p>
-            <a:pPr lvl="0" indent="0" marL="0">
-              <a:buNone/>
-            </a:pPr>
-            <a:r>
-              <a:rPr b="1"/>
-              <a:t>The data is clear:</a:t>
-            </a:r>
-            <a:r>
-              <a:rPr/>
-              <a:t> - 34% of community skill packages are malformed (Skilldex) - 89% of attacks succeed against baseline guardrails (LGA) - 60%+ of tasks have safety violations (BeSafe-Bench) - 40% of agent projects face cancellation (Agent Evaluation Guide) - 73% incident reduction with governance toolkit (Microsoft)</a:t>
-            </a:r>
-          </a:p>
-          <a:p>
-            <a:pPr lvl="0" indent="0" marL="0">
-              <a:buNone/>
-            </a:pPr>
-            <a:r>
-              <a:rPr b="1"/>
-              <a:t>Governance is not optional. It’s the difference between agents that work and agents that are safe to use.</a:t>
+              <a:t>Implementation Roadmap</a:t>
+            </a:r>
+          </a:p>
+          <a:p>
+            <a:pPr lvl="0" indent="0" marL="0">
+              <a:spcBef>
+                <a:spcPts val="3000"/>
+              </a:spcBef>
+              <a:buNone/>
+            </a:pPr>
+            <a:r>
+              <a:rPr b="1"/>
+              <a:t>Immediate (30 days)</a:t>
+            </a:r>
+          </a:p>
+          <a:p>
+            <a:pPr lvl="0" indent="-342900" marL="342900">
+              <a:buAutoNum type="arabicPeriod"/>
+            </a:pPr>
+            <a:r>
+              <a:rPr b="1"/>
+              <a:t>Adopt GovernSpec’s 12 contract sections</a:t>
+            </a:r>
+            <a:r>
+              <a:rPr/>
+              <a:t> for all skill specifications</a:t>
+            </a:r>
+          </a:p>
+          <a:p>
+            <a:pPr lvl="0" indent="-342900" marL="342900">
+              <a:buAutoNum type="arabicPeriod"/>
+            </a:pPr>
+            <a:r>
+              <a:rPr b="1"/>
+              <a:t>Deploy Skilldex</a:t>
+            </a:r>
+            <a:r>
+              <a:rPr/>
+              <a:t> for validation — check 100% of skill packages</a:t>
+            </a:r>
+          </a:p>
+          <a:p>
+            <a:pPr lvl="0" indent="-342900" marL="342900">
+              <a:buAutoNum type="arabicPeriod"/>
+            </a:pPr>
+            <a:r>
+              <a:rPr b="1"/>
+              <a:t>Map existing skills to OWASP Top 10</a:t>
+            </a:r>
+            <a:r>
+              <a:rPr/>
+              <a:t> — identify which risks are unaddressed</a:t>
+            </a:r>
+          </a:p>
+          <a:p>
+            <a:pPr lvl="0" indent="0" marL="0">
+              <a:spcBef>
+                <a:spcPts val="3000"/>
+              </a:spcBef>
+              <a:buNone/>
+            </a:pPr>
+            <a:r>
+              <a:rPr b="1"/>
+              <a:t>Short-term (90 days)</a:t>
+            </a:r>
+          </a:p>
+          <a:p>
+            <a:pPr lvl="0" indent="-342900" marL="342900">
+              <a:buAutoNum startAt="4" type="arabicPeriod"/>
+            </a:pPr>
+            <a:r>
+              <a:rPr b="1"/>
+              <a:t>Implement LGA Layer 1</a:t>
+            </a:r>
+            <a:r>
+              <a:rPr/>
+              <a:t> (sandboxing) for all agent execution</a:t>
+            </a:r>
+          </a:p>
+          <a:p>
+            <a:pPr lvl="0" indent="-342900" marL="342900">
+              <a:buAutoNum startAt="4" type="arabicPeriod"/>
+            </a:pPr>
+            <a:r>
+              <a:rPr b="1"/>
+              <a:t>Deploy ST-WebAgentBench</a:t>
+            </a:r>
+            <a:r>
+              <a:rPr/>
+              <a:t> for web agent evaluation</a:t>
+            </a:r>
+          </a:p>
+          <a:p>
+            <a:pPr lvl="0" indent="-342900" marL="342900">
+              <a:buAutoNum startAt="4" type="arabicPeriod"/>
+            </a:pPr>
+            <a:r>
+              <a:rPr b="1"/>
+              <a:t>Establish baseline</a:t>
+            </a:r>
+            <a:r>
+              <a:rPr/>
+              <a:t> with BeSafe-Bench on current agents</a:t>
+            </a:r>
+          </a:p>
+          <a:p>
+            <a:pPr lvl="0" indent="0" marL="0">
+              <a:spcBef>
+                <a:spcPts val="3000"/>
+              </a:spcBef>
+              <a:buNone/>
+            </a:pPr>
+            <a:r>
+              <a:rPr b="1"/>
+              <a:t>Strategic (12 months)</a:t>
+            </a:r>
+          </a:p>
+          <a:p>
+            <a:pPr lvl="0" indent="-342900" marL="342900">
+              <a:buAutoNum startAt="7" type="arabicPeriod"/>
+            </a:pPr>
+            <a:r>
+              <a:rPr b="1"/>
+              <a:t>Full LGA stack</a:t>
+            </a:r>
+            <a:r>
+              <a:rPr/>
+              <a:t> — all four layers operational</a:t>
+            </a:r>
+          </a:p>
+          <a:p>
+            <a:pPr lvl="0" indent="-342900" marL="342900">
+              <a:buAutoNum startAt="7" type="arabicPeriod"/>
+            </a:pPr>
+            <a:r>
+              <a:rPr b="1"/>
+              <a:t>Microsoft-style governance toolkit</a:t>
+            </a:r>
+            <a:r>
+              <a:rPr/>
+              <a:t> — registration, policy, audit, evaluation, human-in-the-loop</a:t>
+            </a:r>
+          </a:p>
+          <a:p>
+            <a:pPr lvl="0" indent="-342900" marL="342900">
+              <a:buAutoNum startAt="7" type="arabicPeriod"/>
+            </a:pPr>
+            <a:r>
+              <a:rPr b="1"/>
+              <a:t>Continuous evaluation</a:t>
+            </a:r>
+            <a:r>
+              <a:rPr/>
+              <a:t> — weekly safety benchmarks with automated reporting</a:t>
             </a:r>
           </a:p>
         </p:txBody>
@@ -10060,6 +10296,78 @@
 </file>
 
 <file path=ppt/slides/slide40.xml><?xml version="1.0" encoding="utf-8"?>
+<p:sld xmlns:a="http://schemas.openxmlformats.org/drawingml/2006/main" xmlns:r="http://schemas.openxmlformats.org/officeDocument/2006/relationships" xmlns:p="http://schemas.openxmlformats.org/presentationml/2006/main">
+  <p:cSld>
+    <p:spTree>
+      <p:nvGrpSpPr>
+        <p:cNvPr id="1" name=""/>
+        <p:cNvGrpSpPr/>
+        <p:nvPr/>
+      </p:nvGrpSpPr>
+      <p:grpSpPr>
+        <a:xfrm>
+          <a:off x="0" y="0"/>
+          <a:ext cx="0" cy="0"/>
+          <a:chOff x="0" y="0"/>
+          <a:chExt cx="0" cy="0"/>
+        </a:xfrm>
+      </p:grpSpPr>
+      <p:sp>
+        <p:nvSpPr>
+          <p:cNvPr id="3" name="Content Placeholder 2"/>
+          <p:cNvSpPr>
+            <a:spLocks noGrp="1"/>
+          </p:cNvSpPr>
+          <p:nvPr>
+            <p:ph idx="1"/>
+          </p:nvPr>
+        </p:nvSpPr>
+        <p:spPr/>
+        <p:txBody>
+          <a:bodyPr/>
+          <a:lstStyle/>
+          <a:p>
+            <a:pPr lvl="0" indent="0" marL="0">
+              <a:spcBef>
+                <a:spcPts val="3000"/>
+              </a:spcBef>
+              <a:buNone/>
+            </a:pPr>
+            <a:r>
+              <a:rPr b="1"/>
+              <a:t>Why This Matters</a:t>
+            </a:r>
+          </a:p>
+          <a:p>
+            <a:pPr lvl="0" indent="0" marL="0">
+              <a:buNone/>
+            </a:pPr>
+            <a:r>
+              <a:rPr b="1"/>
+              <a:t>The data is clear:</a:t>
+            </a:r>
+            <a:r>
+              <a:rPr/>
+              <a:t> - 34% of community skill packages are malformed (Skilldex) - 89% of attacks succeed against baseline guardrails (LGA) - 60%+ of tasks have safety violations (BeSafe-Bench) - 40% of agent projects face cancellation (Agent Evaluation Guide) - 73% incident reduction with governance toolkit (Microsoft)</a:t>
+            </a:r>
+          </a:p>
+          <a:p>
+            <a:pPr lvl="0" indent="0" marL="0">
+              <a:buNone/>
+            </a:pPr>
+            <a:r>
+              <a:rPr b="1"/>
+              <a:t>Governance is not optional. It’s the difference between agents that work and agents that are safe to use.</a:t>
+            </a:r>
+          </a:p>
+        </p:txBody>
+      </p:sp>
+    </p:spTree>
+  </p:cSld>
+</p:sld>
+</file>
+
+<file path=ppt/slides/slide41.xml><?xml version="1.0" encoding="utf-8"?>
 <p:sld xmlns:a="http://schemas.openxmlformats.org/drawingml/2006/main" xmlns:r="http://schemas.openxmlformats.org/officeDocument/2006/relationships" xmlns:p="http://schemas.openxmlformats.org/presentationml/2006/main">
   <p:cSld>
     <p:spTree>

</xml_diff>